<commit_message>
Finalize cultural selection pilot results and deck
</commit_message>
<xml_diff>
--- a/experiments/2026-07-12-minimal-cultural-selection/deck/minimal-cultural-selection-design.pptx
+++ b/experiments/2026-07-12-minimal-cultural-selection/deck/minimal-cultural-selection-design.pptx
@@ -13,9 +13,11 @@
     <p:sldId id="261" r:id="rId7"/>
     <p:sldId id="262" r:id="rId8"/>
     <p:sldId id="263" r:id="rId9"/>
+    <p:sldId id="264" r:id="rId10"/>
+    <p:sldId id="265" r:id="rId11"/>
   </p:sldIdLst>
   <p:notesMasterIdLst>
-    <p:notesMasterId r:id="rId10"/>
+    <p:notesMasterId r:id="rId12"/>
   </p:notesMasterIdLst>
   <p:sldSz cx="12192000" cy="6858000"/>
   <p:notesSz cx="6858000" cy="12192000"/>
@@ -551,6 +553,94 @@
 </p:notes>
 </file>
 
+<file path=ppt/notesSlides/notesSlide10.xml><?xml version="1.0" encoding="utf-8"?>
+<p:notes xmlns:a="http://schemas.openxmlformats.org/drawingml/2006/main" xmlns:r="http://schemas.openxmlformats.org/officeDocument/2006/relationships" xmlns:p="http://schemas.openxmlformats.org/presentationml/2006/main">
+  <p:cSld>
+    <p:spTree>
+      <p:nvGrpSpPr>
+        <p:cNvPr id="1" name=""/>
+        <p:cNvGrpSpPr/>
+        <p:nvPr/>
+      </p:nvGrpSpPr>
+      <p:grpSpPr>
+        <a:xfrm>
+          <a:off x="0" y="0"/>
+          <a:ext cx="0" cy="0"/>
+          <a:chOff x="0" y="0"/>
+          <a:chExt cx="0" cy="0"/>
+        </a:xfrm>
+      </p:grpSpPr>
+      <p:sp>
+        <p:nvSpPr>
+          <p:cNvPr id="2" name="Slide Image Placeholder 1"/>
+          <p:cNvSpPr>
+            <a:spLocks noGrp="1" noRot="1" noChangeAspect="1"/>
+          </p:cNvSpPr>
+          <p:nvPr>
+            <p:ph type="sldImg"/>
+          </p:nvPr>
+        </p:nvSpPr>
+        <p:spPr/>
+      </p:sp>
+      <p:sp>
+        <p:nvSpPr>
+          <p:cNvPr id="3" name="Notes Placeholder 2"/>
+          <p:cNvSpPr>
+            <a:spLocks noGrp="1"/>
+          </p:cNvSpPr>
+          <p:nvPr>
+            <p:ph type="body" idx="1"/>
+          </p:nvPr>
+        </p:nvSpPr>
+        <p:spPr/>
+        <p:txBody>
+          <a:bodyPr/>
+          <a:lstStyle/>
+          <a:p>
+            <a:r>
+              <a:rPr lang="en-US" dirty="0"/>
+              <a:t/>
+            </a:r>
+            <a:endParaRPr lang="en-US" dirty="0"/>
+          </a:p>
+        </p:txBody>
+      </p:sp>
+      <p:sp>
+        <p:nvSpPr>
+          <p:cNvPr id="4" name="Slide Number Placeholder 3"/>
+          <p:cNvSpPr>
+            <a:spLocks noGrp="1"/>
+          </p:cNvSpPr>
+          <p:nvPr>
+            <p:ph type="sldNum" sz="quarter" idx="10"/>
+          </p:nvPr>
+        </p:nvSpPr>
+        <p:spPr/>
+        <p:txBody>
+          <a:bodyPr/>
+          <a:lstStyle/>
+          <a:p>
+            <a:fld id="{F7021451-1387-4CA6-816F-3879F97B5CBC}" type="slidenum">
+              <a:rPr lang="en-US"/>
+              <a:t>10</a:t>
+            </a:fld>
+            <a:endParaRPr lang="en-US"/>
+          </a:p>
+        </p:txBody>
+      </p:sp>
+    </p:spTree>
+    <p:extLst>
+      <p:ext uri="{BB962C8B-B14F-4D97-AF65-F5344CB8AC3E}">
+        <p14:creationId xmlns:p14="http://schemas.microsoft.com/office/powerpoint/2010/main" val="1024086991"/>
+      </p:ext>
+    </p:extLst>
+  </p:cSld>
+  <p:clrMapOvr>
+    <a:masterClrMapping/>
+  </p:clrMapOvr>
+</p:notes>
+</file>
+
 <file path=ppt/notesSlides/notesSlide2.xml><?xml version="1.0" encoding="utf-8"?>
 <p:notes xmlns:a="http://schemas.openxmlformats.org/drawingml/2006/main" xmlns:r="http://schemas.openxmlformats.org/officeDocument/2006/relationships" xmlns:p="http://schemas.openxmlformats.org/presentationml/2006/main">
   <p:cSld>
@@ -1149,6 +1239,94 @@
             <a:fld id="{F7021451-1387-4CA6-816F-3879F97B5CBC}" type="slidenum">
               <a:rPr lang="en-US"/>
               <a:t>8</a:t>
+            </a:fld>
+            <a:endParaRPr lang="en-US"/>
+          </a:p>
+        </p:txBody>
+      </p:sp>
+    </p:spTree>
+    <p:extLst>
+      <p:ext uri="{BB962C8B-B14F-4D97-AF65-F5344CB8AC3E}">
+        <p14:creationId xmlns:p14="http://schemas.microsoft.com/office/powerpoint/2010/main" val="1024086991"/>
+      </p:ext>
+    </p:extLst>
+  </p:cSld>
+  <p:clrMapOvr>
+    <a:masterClrMapping/>
+  </p:clrMapOvr>
+</p:notes>
+</file>
+
+<file path=ppt/notesSlides/notesSlide9.xml><?xml version="1.0" encoding="utf-8"?>
+<p:notes xmlns:a="http://schemas.openxmlformats.org/drawingml/2006/main" xmlns:r="http://schemas.openxmlformats.org/officeDocument/2006/relationships" xmlns:p="http://schemas.openxmlformats.org/presentationml/2006/main">
+  <p:cSld>
+    <p:spTree>
+      <p:nvGrpSpPr>
+        <p:cNvPr id="1" name=""/>
+        <p:cNvGrpSpPr/>
+        <p:nvPr/>
+      </p:nvGrpSpPr>
+      <p:grpSpPr>
+        <a:xfrm>
+          <a:off x="0" y="0"/>
+          <a:ext cx="0" cy="0"/>
+          <a:chOff x="0" y="0"/>
+          <a:chExt cx="0" cy="0"/>
+        </a:xfrm>
+      </p:grpSpPr>
+      <p:sp>
+        <p:nvSpPr>
+          <p:cNvPr id="2" name="Slide Image Placeholder 1"/>
+          <p:cNvSpPr>
+            <a:spLocks noGrp="1" noRot="1" noChangeAspect="1"/>
+          </p:cNvSpPr>
+          <p:nvPr>
+            <p:ph type="sldImg"/>
+          </p:nvPr>
+        </p:nvSpPr>
+        <p:spPr/>
+      </p:sp>
+      <p:sp>
+        <p:nvSpPr>
+          <p:cNvPr id="3" name="Notes Placeholder 2"/>
+          <p:cNvSpPr>
+            <a:spLocks noGrp="1"/>
+          </p:cNvSpPr>
+          <p:nvPr>
+            <p:ph type="body" idx="1"/>
+          </p:nvPr>
+        </p:nvSpPr>
+        <p:spPr/>
+        <p:txBody>
+          <a:bodyPr/>
+          <a:lstStyle/>
+          <a:p>
+            <a:r>
+              <a:rPr lang="en-US" dirty="0"/>
+              <a:t/>
+            </a:r>
+            <a:endParaRPr lang="en-US" dirty="0"/>
+          </a:p>
+        </p:txBody>
+      </p:sp>
+      <p:sp>
+        <p:nvSpPr>
+          <p:cNvPr id="4" name="Slide Number Placeholder 3"/>
+          <p:cNvSpPr>
+            <a:spLocks noGrp="1"/>
+          </p:cNvSpPr>
+          <p:nvPr>
+            <p:ph type="sldNum" sz="quarter" idx="10"/>
+          </p:nvPr>
+        </p:nvSpPr>
+        <p:spPr/>
+        <p:txBody>
+          <a:bodyPr/>
+          <a:lstStyle/>
+          <a:p>
+            <a:fld id="{F7021451-1387-4CA6-816F-3879F97B5CBC}" type="slidenum">
+              <a:rPr lang="en-US"/>
+              <a:t>9</a:t>
             </a:fld>
             <a:endParaRPr lang="en-US"/>
           </a:p>
@@ -1755,6 +1933,471 @@
 </p:sld>
 </file>
 
+<file path=ppt/slides/slide10.xml><?xml version="1.0" encoding="utf-8"?>
+<p:sld xmlns:a="http://schemas.openxmlformats.org/drawingml/2006/main" xmlns:r="http://schemas.openxmlformats.org/officeDocument/2006/relationships" xmlns:p="http://schemas.openxmlformats.org/presentationml/2006/main">
+  <p:cSld name="Slide 10">
+    <p:bg>
+      <p:bgPr>
+        <a:solidFill>
+          <a:srgbClr val="08090E"/>
+        </a:solidFill>
+      </p:bgPr>
+    </p:bg>
+    <p:spTree>
+      <p:nvGrpSpPr>
+        <p:cNvPr id="1" name=""/>
+        <p:cNvGrpSpPr/>
+        <p:nvPr/>
+      </p:nvGrpSpPr>
+      <p:grpSpPr>
+        <a:xfrm>
+          <a:off x="0" y="0"/>
+          <a:ext cx="0" cy="0"/>
+          <a:chOff x="0" y="0"/>
+          <a:chExt cx="0" cy="0"/>
+        </a:xfrm>
+      </p:grpSpPr>
+      <p:sp>
+        <p:nvSpPr>
+          <p:cNvPr id="2" name="Text 0"/>
+          <p:cNvSpPr/>
+          <p:nvPr/>
+        </p:nvSpPr>
+        <p:spPr>
+          <a:xfrm>
+            <a:off x="502920" y="228600"/>
+            <a:ext cx="3840480" cy="201168"/>
+          </a:xfrm>
+          <a:prstGeom prst="rect">
+            <a:avLst/>
+          </a:prstGeom>
+          <a:noFill/>
+          <a:ln/>
+        </p:spPr>
+        <p:txBody>
+          <a:bodyPr wrap="square" lIns="0" tIns="0" rIns="0" bIns="0" rtlCol="0" anchor="ctr"/>
+          <a:lstStyle/>
+          <a:p>
+            <a:pPr indent="0" marL="0">
+              <a:buNone/>
+            </a:pPr>
+            <a:r>
+              <a:rPr lang="en-US" sz="900" b="1" spc="220" kern="0" dirty="0">
+                <a:solidFill>
+                  <a:srgbClr val="D5BF55"/>
+                </a:solidFill>
+                <a:latin typeface="Aptos" pitchFamily="34" charset="0"/>
+                <a:ea typeface="Aptos" pitchFamily="34" charset="-122"/>
+                <a:cs typeface="Aptos" pitchFamily="34" charset="-120"/>
+              </a:rPr>
+              <a:t>RELIGION &amp; THE MACHINE</a:t>
+            </a:r>
+            <a:endParaRPr lang="en-US" sz="900" dirty="0"/>
+          </a:p>
+        </p:txBody>
+      </p:sp>
+      <p:sp>
+        <p:nvSpPr>
+          <p:cNvPr id="3" name="Text 1"/>
+          <p:cNvSpPr/>
+          <p:nvPr/>
+        </p:nvSpPr>
+        <p:spPr>
+          <a:xfrm>
+            <a:off x="11155680" y="228600"/>
+            <a:ext cx="502920" cy="201168"/>
+          </a:xfrm>
+          <a:prstGeom prst="rect">
+            <a:avLst/>
+          </a:prstGeom>
+          <a:noFill/>
+          <a:ln/>
+        </p:spPr>
+        <p:txBody>
+          <a:bodyPr wrap="square" lIns="0" tIns="0" rIns="0" bIns="0" rtlCol="0" anchor="ctr"/>
+          <a:lstStyle/>
+          <a:p>
+            <a:pPr algn="r" indent="0" marL="0">
+              <a:buNone/>
+            </a:pPr>
+            <a:r>
+              <a:rPr lang="en-US" sz="900" dirty="0">
+                <a:solidFill>
+                  <a:srgbClr val="A8A7B5"/>
+                </a:solidFill>
+              </a:rPr>
+              <a:t>10</a:t>
+            </a:r>
+            <a:endParaRPr lang="en-US" sz="900" dirty="0"/>
+          </a:p>
+        </p:txBody>
+      </p:sp>
+      <p:sp>
+        <p:nvSpPr>
+          <p:cNvPr id="4" name="Text 2"/>
+          <p:cNvSpPr/>
+          <p:nvPr/>
+        </p:nvSpPr>
+        <p:spPr>
+          <a:xfrm>
+            <a:off x="530352" y="658368"/>
+            <a:ext cx="8138160" cy="566928"/>
+          </a:xfrm>
+          <a:prstGeom prst="rect">
+            <a:avLst/>
+          </a:prstGeom>
+          <a:noFill/>
+          <a:ln/>
+        </p:spPr>
+        <p:txBody>
+          <a:bodyPr wrap="square" lIns="0" tIns="0" rIns="0" bIns="0" rtlCol="0" anchor="ctr"/>
+          <a:lstStyle/>
+          <a:p>
+            <a:pPr indent="0" marL="0">
+              <a:buNone/>
+            </a:pPr>
+            <a:r>
+              <a:rPr lang="en-US" sz="3000" dirty="0">
+                <a:solidFill>
+                  <a:srgbClr val="EEECE4"/>
+                </a:solidFill>
+                <a:latin typeface="Georgia" pitchFamily="34" charset="0"/>
+                <a:ea typeface="Georgia" pitchFamily="34" charset="-122"/>
+                <a:cs typeface="Georgia" pitchFamily="34" charset="-120"/>
+              </a:rPr>
+              <a:t>Selection created culture—and a fashion</a:t>
+            </a:r>
+            <a:endParaRPr lang="en-US" sz="3000" dirty="0"/>
+          </a:p>
+        </p:txBody>
+      </p:sp>
+      <p:sp>
+        <p:nvSpPr>
+          <p:cNvPr id="5" name="Text 3"/>
+          <p:cNvSpPr/>
+          <p:nvPr/>
+        </p:nvSpPr>
+        <p:spPr>
+          <a:xfrm>
+            <a:off x="548640" y="1280160"/>
+            <a:ext cx="8686800" cy="411480"/>
+          </a:xfrm>
+          <a:prstGeom prst="rect">
+            <a:avLst/>
+          </a:prstGeom>
+          <a:noFill/>
+          <a:ln/>
+        </p:spPr>
+        <p:txBody>
+          <a:bodyPr wrap="square" lIns="0" tIns="0" rIns="0" bIns="0" rtlCol="0" anchor="ctr"/>
+          <a:lstStyle/>
+          <a:p>
+            <a:pPr indent="0" marL="0">
+              <a:buNone/>
+            </a:pPr>
+            <a:r>
+              <a:rPr lang="en-US" sz="1400" dirty="0">
+                <a:solidFill>
+                  <a:srgbClr val="A8A7B5"/>
+                </a:solidFill>
+              </a:rPr>
+              <a:t>The mechanism worked. Its first equilibrium was imitation.</a:t>
+            </a:r>
+            <a:endParaRPr lang="en-US" sz="1400" dirty="0"/>
+          </a:p>
+        </p:txBody>
+      </p:sp>
+      <p:sp>
+        <p:nvSpPr>
+          <p:cNvPr id="6" name="Shape 4"/>
+          <p:cNvSpPr/>
+          <p:nvPr/>
+        </p:nvSpPr>
+        <p:spPr>
+          <a:xfrm>
+            <a:off x="658368" y="1828800"/>
+            <a:ext cx="5166360" cy="3246120"/>
+          </a:xfrm>
+          <a:prstGeom prst="rect">
+            <a:avLst/>
+          </a:prstGeom>
+          <a:solidFill>
+            <a:srgbClr val="11131C"/>
+          </a:solidFill>
+          <a:ln w="12700">
+            <a:solidFill>
+              <a:srgbClr val="292C3B"/>
+            </a:solidFill>
+            <a:prstDash val="solid"/>
+          </a:ln>
+        </p:spPr>
+      </p:sp>
+      <p:sp>
+        <p:nvSpPr>
+          <p:cNvPr id="7" name="Shape 5"/>
+          <p:cNvSpPr/>
+          <p:nvPr/>
+        </p:nvSpPr>
+        <p:spPr>
+          <a:xfrm>
+            <a:off x="658368" y="1828800"/>
+            <a:ext cx="64008" cy="3246120"/>
+          </a:xfrm>
+          <a:prstGeom prst="rect">
+            <a:avLst/>
+          </a:prstGeom>
+          <a:solidFill>
+            <a:srgbClr val="74B86A"/>
+          </a:solidFill>
+          <a:ln w="12700">
+            <a:solidFill>
+              <a:srgbClr val="74B86A"/>
+            </a:solidFill>
+            <a:prstDash val="solid"/>
+          </a:ln>
+        </p:spPr>
+      </p:sp>
+      <p:sp>
+        <p:nvSpPr>
+          <p:cNvPr id="8" name="Text 6"/>
+          <p:cNvSpPr/>
+          <p:nvPr/>
+        </p:nvSpPr>
+        <p:spPr>
+          <a:xfrm>
+            <a:off x="886968" y="2029968"/>
+            <a:ext cx="4754880" cy="320040"/>
+          </a:xfrm>
+          <a:prstGeom prst="rect">
+            <a:avLst/>
+          </a:prstGeom>
+          <a:noFill/>
+          <a:ln/>
+        </p:spPr>
+        <p:txBody>
+          <a:bodyPr wrap="square" lIns="0" tIns="0" rIns="0" bIns="0" rtlCol="0" anchor="ctr"/>
+          <a:lstStyle/>
+          <a:p>
+            <a:pPr indent="0" marL="0">
+              <a:buNone/>
+            </a:pPr>
+            <a:r>
+              <a:rPr lang="en-US" sz="1600" b="1" dirty="0">
+                <a:solidFill>
+                  <a:srgbClr val="EEECE4"/>
+                </a:solidFill>
+              </a:rPr>
+              <a:t>WHAT EMERGED</a:t>
+            </a:r>
+            <a:endParaRPr lang="en-US" sz="1600" dirty="0"/>
+          </a:p>
+        </p:txBody>
+      </p:sp>
+      <p:sp>
+        <p:nvSpPr>
+          <p:cNvPr id="9" name="Text 7"/>
+          <p:cNvSpPr/>
+          <p:nvPr/>
+        </p:nvSpPr>
+        <p:spPr>
+          <a:xfrm>
+            <a:off x="886968" y="2487168"/>
+            <a:ext cx="4754880" cy="2423160"/>
+          </a:xfrm>
+          <a:prstGeom prst="rect">
+            <a:avLst/>
+          </a:prstGeom>
+          <a:noFill/>
+          <a:ln/>
+        </p:spPr>
+        <p:txBody>
+          <a:bodyPr wrap="square" lIns="0" tIns="0" rIns="0" bIns="0" rtlCol="0" anchor="t"/>
+          <a:lstStyle/>
+          <a:p>
+            <a:pPr indent="0" marL="0">
+              <a:buNone/>
+            </a:pPr>
+            <a:r>
+              <a:rPr lang="en-US" sz="1250" dirty="0">
+                <a:solidFill>
+                  <a:srgbClr val="A8A7B5"/>
+                </a:solidFill>
+              </a:rPr>
+              <a:t>Agents voluntarily spent survival time making. Other agents inspected and chose their work. Animation spread because agents explicitly observed that it attracted support.</a:t>
+            </a:r>
+            <a:endParaRPr lang="en-US" sz="1250" dirty="0"/>
+          </a:p>
+        </p:txBody>
+      </p:sp>
+      <p:sp>
+        <p:nvSpPr>
+          <p:cNvPr id="10" name="Shape 8"/>
+          <p:cNvSpPr/>
+          <p:nvPr/>
+        </p:nvSpPr>
+        <p:spPr>
+          <a:xfrm>
+            <a:off x="6355080" y="1828800"/>
+            <a:ext cx="5166360" cy="3246120"/>
+          </a:xfrm>
+          <a:prstGeom prst="rect">
+            <a:avLst/>
+          </a:prstGeom>
+          <a:solidFill>
+            <a:srgbClr val="11131C"/>
+          </a:solidFill>
+          <a:ln w="12700">
+            <a:solidFill>
+              <a:srgbClr val="292C3B"/>
+            </a:solidFill>
+            <a:prstDash val="solid"/>
+          </a:ln>
+        </p:spPr>
+      </p:sp>
+      <p:sp>
+        <p:nvSpPr>
+          <p:cNvPr id="11" name="Shape 9"/>
+          <p:cNvSpPr/>
+          <p:nvPr/>
+        </p:nvSpPr>
+        <p:spPr>
+          <a:xfrm>
+            <a:off x="6355080" y="1828800"/>
+            <a:ext cx="64008" cy="3246120"/>
+          </a:xfrm>
+          <a:prstGeom prst="rect">
+            <a:avLst/>
+          </a:prstGeom>
+          <a:solidFill>
+            <a:srgbClr val="EF8354"/>
+          </a:solidFill>
+          <a:ln w="12700">
+            <a:solidFill>
+              <a:srgbClr val="EF8354"/>
+            </a:solidFill>
+            <a:prstDash val="solid"/>
+          </a:ln>
+        </p:spPr>
+      </p:sp>
+      <p:sp>
+        <p:nvSpPr>
+          <p:cNvPr id="12" name="Text 10"/>
+          <p:cNvSpPr/>
+          <p:nvPr/>
+        </p:nvSpPr>
+        <p:spPr>
+          <a:xfrm>
+            <a:off x="6583680" y="2029968"/>
+            <a:ext cx="4754880" cy="320040"/>
+          </a:xfrm>
+          <a:prstGeom prst="rect">
+            <a:avLst/>
+          </a:prstGeom>
+          <a:noFill/>
+          <a:ln/>
+        </p:spPr>
+        <p:txBody>
+          <a:bodyPr wrap="square" lIns="0" tIns="0" rIns="0" bIns="0" rtlCol="0" anchor="ctr"/>
+          <a:lstStyle/>
+          <a:p>
+            <a:pPr indent="0" marL="0">
+              <a:buNone/>
+            </a:pPr>
+            <a:r>
+              <a:rPr lang="en-US" sz="1600" b="1" dirty="0">
+                <a:solidFill>
+                  <a:srgbClr val="EEECE4"/>
+                </a:solidFill>
+              </a:rPr>
+              <a:t>WHAT CONVERGED</a:t>
+            </a:r>
+            <a:endParaRPr lang="en-US" sz="1600" dirty="0"/>
+          </a:p>
+        </p:txBody>
+      </p:sp>
+      <p:sp>
+        <p:nvSpPr>
+          <p:cNvPr id="13" name="Text 11"/>
+          <p:cNvSpPr/>
+          <p:nvPr/>
+        </p:nvSpPr>
+        <p:spPr>
+          <a:xfrm>
+            <a:off x="6583680" y="2487168"/>
+            <a:ext cx="4754880" cy="2423160"/>
+          </a:xfrm>
+          <a:prstGeom prst="rect">
+            <a:avLst/>
+          </a:prstGeom>
+          <a:noFill/>
+          <a:ln/>
+        </p:spPr>
+        <p:txBody>
+          <a:bodyPr wrap="square" lIns="0" tIns="0" rIns="0" bIns="0" rtlCol="0" anchor="t"/>
+          <a:lstStyle/>
+          <a:p>
+            <a:pPr indent="0" marL="0">
+              <a:buNone/>
+            </a:pPr>
+            <a:r>
+              <a:rPr lang="en-US" sz="1250" dirty="0">
+                <a:solidFill>
+                  <a:srgbClr val="A8A7B5"/>
+                </a:solidFill>
+              </a:rPr>
+              <a:t>Four religions kept distinct colors and doctrines, but adopted the same dark field, glowing ring, tilted square, central title, and subtle motion. Safe evolution beat radical invention.</a:t>
+            </a:r>
+            <a:endParaRPr lang="en-US" sz="1250" dirty="0"/>
+          </a:p>
+        </p:txBody>
+      </p:sp>
+      <p:sp>
+        <p:nvSpPr>
+          <p:cNvPr id="14" name="Text 12"/>
+          <p:cNvSpPr/>
+          <p:nvPr/>
+        </p:nvSpPr>
+        <p:spPr>
+          <a:xfrm>
+            <a:off x="1234440" y="5669280"/>
+            <a:ext cx="9738360" cy="411480"/>
+          </a:xfrm>
+          <a:prstGeom prst="rect">
+            <a:avLst/>
+          </a:prstGeom>
+          <a:noFill/>
+          <a:ln/>
+        </p:spPr>
+        <p:txBody>
+          <a:bodyPr wrap="square" lIns="0" tIns="0" rIns="0" bIns="0" rtlCol="0" anchor="ctr"/>
+          <a:lstStyle/>
+          <a:p>
+            <a:pPr algn="ctr" indent="0" marL="0">
+              <a:buNone/>
+            </a:pPr>
+            <a:r>
+              <a:rPr lang="en-US" sz="2400" dirty="0">
+                <a:solidFill>
+                  <a:srgbClr val="D5BF55"/>
+                </a:solidFill>
+                <a:latin typeface="Georgia" pitchFamily="34" charset="0"/>
+                <a:ea typeface="Georgia" pitchFamily="34" charset="-122"/>
+                <a:cs typeface="Georgia" pitchFamily="34" charset="-120"/>
+              </a:rPr>
+              <a:t>Social selection made art instrumental. It did not, by itself, make art diverse.</a:t>
+            </a:r>
+            <a:endParaRPr lang="en-US" sz="2400" dirty="0"/>
+          </a:p>
+        </p:txBody>
+      </p:sp>
+    </p:spTree>
+  </p:cSld>
+  <p:clrMapOvr>
+    <a:masterClrMapping/>
+  </p:clrMapOvr>
+</p:sld>
+</file>
+
 <file path=ppt/slides/slide2.xml><?xml version="1.0" encoding="utf-8"?>
 <p:sld xmlns:a="http://schemas.openxmlformats.org/drawingml/2006/main" xmlns:r="http://schemas.openxmlformats.org/officeDocument/2006/relationships" xmlns:p="http://schemas.openxmlformats.org/presentationml/2006/main">
   <p:cSld name="Slide 2">
@@ -3546,7 +4189,7 @@
       </p:sp>
       <p:pic>
         <p:nvPicPr>
-          <p:cNvPr id="6" name="Image 0" descr="/home/aenguslynch/projects/messiah-bench/outputs/2026-07-12-minimal-cultural-selection-smoke1/renders/version-1.png">    </p:cNvPr>
+          <p:cNvPr id="6" name="Image 0" descr="/home/aenguslynch/projects/messiah-bench/outputs/2026-07-12-minimal-cultural-selection/renders/version-25.png">    </p:cNvPr>
           <p:cNvPicPr>
             <a:picLocks noChangeAspect="1"/>
           </p:cNvPicPr>
@@ -3597,7 +4240,7 @@
       </p:sp>
       <p:pic>
         <p:nvPicPr>
-          <p:cNvPr id="8" name="Image 1" descr="/home/aenguslynch/projects/messiah-bench/outputs/2026-07-12-minimal-cultural-selection-smoke1/renders/version-2.png">    </p:cNvPr>
+          <p:cNvPr id="8" name="Image 1" descr="/home/aenguslynch/projects/messiah-bench/outputs/2026-07-12-minimal-cultural-selection/renders/version-22.png">    </p:cNvPr>
           <p:cNvPicPr>
             <a:picLocks noChangeAspect="1"/>
           </p:cNvPicPr>
@@ -3648,7 +4291,7 @@
       </p:sp>
       <p:pic>
         <p:nvPicPr>
-          <p:cNvPr id="10" name="Image 2" descr="/home/aenguslynch/projects/messiah-bench/outputs/2026-07-12-minimal-cultural-selection-smoke1/renders/version-3.png">    </p:cNvPr>
+          <p:cNvPr id="10" name="Image 2" descr="/home/aenguslynch/projects/messiah-bench/outputs/2026-07-12-minimal-cultural-selection/renders/version-23.png">    </p:cNvPr>
           <p:cNvPicPr>
             <a:picLocks noChangeAspect="1"/>
           </p:cNvPicPr>
@@ -3699,7 +4342,7 @@
       </p:sp>
       <p:pic>
         <p:nvPicPr>
-          <p:cNvPr id="12" name="Image 3" descr="/home/aenguslynch/projects/messiah-bench/outputs/2026-07-12-minimal-cultural-selection-smoke1/renders/version-4.png">    </p:cNvPr>
+          <p:cNvPr id="12" name="Image 3" descr="/home/aenguslynch/projects/messiah-bench/outputs/2026-07-12-minimal-cultural-selection/renders/version-24.png">    </p:cNvPr>
           <p:cNvPicPr>
             <a:picLocks noChangeAspect="1"/>
           </p:cNvPicPr>
@@ -6389,7 +7032,7 @@
                   <a:srgbClr val="A8A7B5"/>
                 </a:solidFill>
               </a:rPr>
-              <a:t>NEXT</a:t>
+              <a:t>PASSED</a:t>
             </a:r>
             <a:endParaRPr lang="en-US" sz="900" dirty="0"/>
           </a:p>
@@ -6489,7 +7132,7 @@
                   <a:srgbClr val="EEECE4"/>
                 </a:solidFill>
               </a:rPr>
-              <a:t>REPLICATE</a:t>
+              <a:t>EXHIBIT</a:t>
             </a:r>
             <a:endParaRPr lang="en-US" sz="1400" dirty="0"/>
           </a:p>
@@ -6525,7 +7168,7 @@
                   <a:srgbClr val="A8A7B5"/>
                 </a:solidFill>
               </a:rPr>
-              <a:t>5 seeds</a:t>
+              <a:t>live public website</a:t>
             </a:r>
             <a:endParaRPr lang="en-US" sz="1200" dirty="0"/>
           </a:p>
@@ -6561,7 +7204,7 @@
                   <a:srgbClr val="A8A7B5"/>
                 </a:solidFill>
               </a:rPr>
-              <a:t>PENDING</a:t>
+              <a:t>LIVE</a:t>
             </a:r>
             <a:endParaRPr lang="en-US" sz="900" dirty="0"/>
           </a:p>
@@ -6661,7 +7304,7 @@
                   <a:srgbClr val="EEECE4"/>
                 </a:solidFill>
               </a:rPr>
-              <a:t>EXHIBIT</a:t>
+              <a:t>REPLICATE</a:t>
             </a:r>
             <a:endParaRPr lang="en-US" sz="1400" dirty="0"/>
           </a:p>
@@ -6697,7 +7340,7 @@
                   <a:srgbClr val="A8A7B5"/>
                 </a:solidFill>
               </a:rPr>
-              <a:t>live lineage website</a:t>
+              <a:t>5 seeds</a:t>
             </a:r>
             <a:endParaRPr lang="en-US" sz="1200" dirty="0"/>
           </a:p>
@@ -6733,7 +7376,7 @@
                   <a:srgbClr val="A8A7B5"/>
                 </a:solidFill>
               </a:rPr>
-              <a:t>PENDING</a:t>
+              <a:t>NEXT</a:t>
             </a:r>
             <a:endParaRPr lang="en-US" sz="900" dirty="0"/>
           </a:p>
@@ -6919,9 +7562,828 @@
                   <a:srgbClr val="D5BF55"/>
                 </a:solidFill>
               </a:rPr>
-              <a:t>Deck and website update in place as evidence arrives.</a:t>
+              <a:t>Pilot complete. The next question is whether the pattern replicates.</a:t>
             </a:r>
             <a:endParaRPr lang="en-US" sz="1700" dirty="0"/>
+          </a:p>
+        </p:txBody>
+      </p:sp>
+    </p:spTree>
+  </p:cSld>
+  <p:clrMapOvr>
+    <a:masterClrMapping/>
+  </p:clrMapOvr>
+</p:sld>
+</file>
+
+<file path=ppt/slides/slide9.xml><?xml version="1.0" encoding="utf-8"?>
+<p:sld xmlns:a="http://schemas.openxmlformats.org/drawingml/2006/main" xmlns:r="http://schemas.openxmlformats.org/officeDocument/2006/relationships" xmlns:p="http://schemas.openxmlformats.org/presentationml/2006/main">
+  <p:cSld name="Slide 9">
+    <p:bg>
+      <p:bgPr>
+        <a:solidFill>
+          <a:srgbClr val="F3F0E7"/>
+        </a:solidFill>
+      </p:bgPr>
+    </p:bg>
+    <p:spTree>
+      <p:nvGrpSpPr>
+        <p:cNvPr id="1" name=""/>
+        <p:cNvGrpSpPr/>
+        <p:nvPr/>
+      </p:nvGrpSpPr>
+      <p:grpSpPr>
+        <a:xfrm>
+          <a:off x="0" y="0"/>
+          <a:ext cx="0" cy="0"/>
+          <a:chOff x="0" y="0"/>
+          <a:chExt cx="0" cy="0"/>
+        </a:xfrm>
+      </p:grpSpPr>
+      <p:sp>
+        <p:nvSpPr>
+          <p:cNvPr id="2" name="Text 0"/>
+          <p:cNvSpPr/>
+          <p:nvPr/>
+        </p:nvSpPr>
+        <p:spPr>
+          <a:xfrm>
+            <a:off x="502920" y="228600"/>
+            <a:ext cx="3840480" cy="201168"/>
+          </a:xfrm>
+          <a:prstGeom prst="rect">
+            <a:avLst/>
+          </a:prstGeom>
+          <a:noFill/>
+          <a:ln/>
+        </p:spPr>
+        <p:txBody>
+          <a:bodyPr wrap="square" lIns="0" tIns="0" rIns="0" bIns="0" rtlCol="0" anchor="ctr"/>
+          <a:lstStyle/>
+          <a:p>
+            <a:pPr indent="0" marL="0">
+              <a:buNone/>
+            </a:pPr>
+            <a:r>
+              <a:rPr lang="en-US" sz="900" b="1" spc="220" kern="0" dirty="0">
+                <a:solidFill>
+                  <a:srgbClr val="756A29"/>
+                </a:solidFill>
+                <a:latin typeface="Aptos" pitchFamily="34" charset="0"/>
+                <a:ea typeface="Aptos" pitchFamily="34" charset="-122"/>
+                <a:cs typeface="Aptos" pitchFamily="34" charset="-120"/>
+              </a:rPr>
+              <a:t>RELIGION &amp; THE MACHINE</a:t>
+            </a:r>
+            <a:endParaRPr lang="en-US" sz="900" dirty="0"/>
+          </a:p>
+        </p:txBody>
+      </p:sp>
+      <p:sp>
+        <p:nvSpPr>
+          <p:cNvPr id="3" name="Text 1"/>
+          <p:cNvSpPr/>
+          <p:nvPr/>
+        </p:nvSpPr>
+        <p:spPr>
+          <a:xfrm>
+            <a:off x="11155680" y="228600"/>
+            <a:ext cx="502920" cy="201168"/>
+          </a:xfrm>
+          <a:prstGeom prst="rect">
+            <a:avLst/>
+          </a:prstGeom>
+          <a:noFill/>
+          <a:ln/>
+        </p:spPr>
+        <p:txBody>
+          <a:bodyPr wrap="square" lIns="0" tIns="0" rIns="0" bIns="0" rtlCol="0" anchor="ctr"/>
+          <a:lstStyle/>
+          <a:p>
+            <a:pPr algn="r" indent="0" marL="0">
+              <a:buNone/>
+            </a:pPr>
+            <a:r>
+              <a:rPr lang="en-US" sz="900" dirty="0">
+                <a:solidFill>
+                  <a:srgbClr val="6B6870"/>
+                </a:solidFill>
+              </a:rPr>
+              <a:t>09</a:t>
+            </a:r>
+            <a:endParaRPr lang="en-US" sz="900" dirty="0"/>
+          </a:p>
+        </p:txBody>
+      </p:sp>
+      <p:sp>
+        <p:nvSpPr>
+          <p:cNvPr id="4" name="Text 2"/>
+          <p:cNvSpPr/>
+          <p:nvPr/>
+        </p:nvSpPr>
+        <p:spPr>
+          <a:xfrm>
+            <a:off x="530352" y="658368"/>
+            <a:ext cx="8138160" cy="566928"/>
+          </a:xfrm>
+          <a:prstGeom prst="rect">
+            <a:avLst/>
+          </a:prstGeom>
+          <a:noFill/>
+          <a:ln/>
+        </p:spPr>
+        <p:txBody>
+          <a:bodyPr wrap="square" lIns="0" tIns="0" rIns="0" bIns="0" rtlCol="0" anchor="ctr"/>
+          <a:lstStyle/>
+          <a:p>
+            <a:pPr indent="0" marL="0">
+              <a:buNone/>
+            </a:pPr>
+            <a:r>
+              <a:rPr lang="en-US" sz="3000" dirty="0">
+                <a:solidFill>
+                  <a:srgbClr val="191A20"/>
+                </a:solidFill>
+                <a:latin typeface="Georgia" pitchFamily="34" charset="0"/>
+                <a:ea typeface="Georgia" pitchFamily="34" charset="-122"/>
+                <a:cs typeface="Georgia" pitchFamily="34" charset="-120"/>
+              </a:rPr>
+              <a:t>The pilot completed cleanly</a:t>
+            </a:r>
+            <a:endParaRPr lang="en-US" sz="3000" dirty="0"/>
+          </a:p>
+        </p:txBody>
+      </p:sp>
+      <p:sp>
+        <p:nvSpPr>
+          <p:cNvPr id="5" name="Text 3"/>
+          <p:cNvSpPr/>
+          <p:nvPr/>
+        </p:nvSpPr>
+        <p:spPr>
+          <a:xfrm>
+            <a:off x="548640" y="1280160"/>
+            <a:ext cx="8686800" cy="411480"/>
+          </a:xfrm>
+          <a:prstGeom prst="rect">
+            <a:avLst/>
+          </a:prstGeom>
+          <a:noFill/>
+          <a:ln/>
+        </p:spPr>
+        <p:txBody>
+          <a:bodyPr wrap="square" lIns="0" tIns="0" rIns="0" bIns="0" rtlCol="0" anchor="ctr"/>
+          <a:lstStyle/>
+          <a:p>
+            <a:pPr indent="0" marL="0">
+              <a:buNone/>
+            </a:pPr>
+            <a:r>
+              <a:rPr lang="en-US" sz="1400" dirty="0">
+                <a:solidFill>
+                  <a:srgbClr val="615F67"/>
+                </a:solidFill>
+              </a:rPr>
+              <a:t>One hundred turns of cultural selection, with no direct reward for making.</a:t>
+            </a:r>
+            <a:endParaRPr lang="en-US" sz="1400" dirty="0"/>
+          </a:p>
+        </p:txBody>
+      </p:sp>
+      <p:sp>
+        <p:nvSpPr>
+          <p:cNvPr id="6" name="Shape 4"/>
+          <p:cNvSpPr/>
+          <p:nvPr/>
+        </p:nvSpPr>
+        <p:spPr>
+          <a:xfrm>
+            <a:off x="594360" y="1920240"/>
+            <a:ext cx="2514600" cy="1965960"/>
+          </a:xfrm>
+          <a:prstGeom prst="rect">
+            <a:avLst/>
+          </a:prstGeom>
+          <a:solidFill>
+            <a:srgbClr val="FFFFFF"/>
+          </a:solidFill>
+          <a:ln w="12700">
+            <a:solidFill>
+              <a:srgbClr val="D6D1C5"/>
+            </a:solidFill>
+            <a:prstDash val="solid"/>
+          </a:ln>
+        </p:spPr>
+      </p:sp>
+      <p:sp>
+        <p:nvSpPr>
+          <p:cNvPr id="7" name="Shape 5"/>
+          <p:cNvSpPr/>
+          <p:nvPr/>
+        </p:nvSpPr>
+        <p:spPr>
+          <a:xfrm>
+            <a:off x="594360" y="1920240"/>
+            <a:ext cx="2514600" cy="82296"/>
+          </a:xfrm>
+          <a:prstGeom prst="rect">
+            <a:avLst/>
+          </a:prstGeom>
+          <a:solidFill>
+            <a:srgbClr val="74B86A"/>
+          </a:solidFill>
+          <a:ln w="12700">
+            <a:solidFill>
+              <a:srgbClr val="74B86A"/>
+            </a:solidFill>
+            <a:prstDash val="solid"/>
+          </a:ln>
+        </p:spPr>
+      </p:sp>
+      <p:sp>
+        <p:nvSpPr>
+          <p:cNvPr id="8" name="Text 6"/>
+          <p:cNvSpPr/>
+          <p:nvPr/>
+        </p:nvSpPr>
+        <p:spPr>
+          <a:xfrm>
+            <a:off x="795528" y="2395728"/>
+            <a:ext cx="2103120" cy="621792"/>
+          </a:xfrm>
+          <a:prstGeom prst="rect">
+            <a:avLst/>
+          </a:prstGeom>
+          <a:noFill/>
+          <a:ln/>
+        </p:spPr>
+        <p:txBody>
+          <a:bodyPr wrap="square" lIns="0" tIns="0" rIns="0" bIns="0" rtlCol="0" anchor="ctr"/>
+          <a:lstStyle/>
+          <a:p>
+            <a:pPr algn="ctr" indent="0" marL="0">
+              <a:buNone/>
+            </a:pPr>
+            <a:r>
+              <a:rPr lang="en-US" sz="3400" dirty="0">
+                <a:solidFill>
+                  <a:srgbClr val="1D1E24"/>
+                </a:solidFill>
+                <a:latin typeface="Georgia" pitchFamily="34" charset="0"/>
+                <a:ea typeface="Georgia" pitchFamily="34" charset="-122"/>
+                <a:cs typeface="Georgia" pitchFamily="34" charset="-120"/>
+              </a:rPr>
+              <a:t>24 / 24</a:t>
+            </a:r>
+            <a:endParaRPr lang="en-US" sz="3400" dirty="0"/>
+          </a:p>
+        </p:txBody>
+      </p:sp>
+      <p:sp>
+        <p:nvSpPr>
+          <p:cNvPr id="9" name="Text 7"/>
+          <p:cNvSpPr/>
+          <p:nvPr/>
+        </p:nvSpPr>
+        <p:spPr>
+          <a:xfrm>
+            <a:off x="777240" y="3200400"/>
+            <a:ext cx="2148840" cy="256032"/>
+          </a:xfrm>
+          <a:prstGeom prst="rect">
+            <a:avLst/>
+          </a:prstGeom>
+          <a:noFill/>
+          <a:ln/>
+        </p:spPr>
+        <p:txBody>
+          <a:bodyPr wrap="square" lIns="0" tIns="0" rIns="0" bIns="0" rtlCol="0" anchor="ctr"/>
+          <a:lstStyle/>
+          <a:p>
+            <a:pPr algn="ctr" indent="0" marL="0">
+              <a:buNone/>
+            </a:pPr>
+            <a:r>
+              <a:rPr lang="en-US" sz="1000" b="1" spc="130" kern="0" dirty="0">
+                <a:solidFill>
+                  <a:srgbClr val="77737B"/>
+                </a:solidFill>
+              </a:rPr>
+              <a:t>AGENTS SURVIVED</a:t>
+            </a:r>
+            <a:endParaRPr lang="en-US" sz="1000" dirty="0"/>
+          </a:p>
+        </p:txBody>
+      </p:sp>
+      <p:sp>
+        <p:nvSpPr>
+          <p:cNvPr id="10" name="Shape 8"/>
+          <p:cNvSpPr/>
+          <p:nvPr/>
+        </p:nvSpPr>
+        <p:spPr>
+          <a:xfrm>
+            <a:off x="3474720" y="1920240"/>
+            <a:ext cx="2514600" cy="1965960"/>
+          </a:xfrm>
+          <a:prstGeom prst="rect">
+            <a:avLst/>
+          </a:prstGeom>
+          <a:solidFill>
+            <a:srgbClr val="FFFFFF"/>
+          </a:solidFill>
+          <a:ln w="12700">
+            <a:solidFill>
+              <a:srgbClr val="D6D1C5"/>
+            </a:solidFill>
+            <a:prstDash val="solid"/>
+          </a:ln>
+        </p:spPr>
+      </p:sp>
+      <p:sp>
+        <p:nvSpPr>
+          <p:cNvPr id="11" name="Shape 9"/>
+          <p:cNvSpPr/>
+          <p:nvPr/>
+        </p:nvSpPr>
+        <p:spPr>
+          <a:xfrm>
+            <a:off x="3474720" y="1920240"/>
+            <a:ext cx="2514600" cy="82296"/>
+          </a:xfrm>
+          <a:prstGeom prst="rect">
+            <a:avLst/>
+          </a:prstGeom>
+          <a:solidFill>
+            <a:srgbClr val="64C9E8"/>
+          </a:solidFill>
+          <a:ln w="12700">
+            <a:solidFill>
+              <a:srgbClr val="64C9E8"/>
+            </a:solidFill>
+            <a:prstDash val="solid"/>
+          </a:ln>
+        </p:spPr>
+      </p:sp>
+      <p:sp>
+        <p:nvSpPr>
+          <p:cNvPr id="12" name="Text 10"/>
+          <p:cNvSpPr/>
+          <p:nvPr/>
+        </p:nvSpPr>
+        <p:spPr>
+          <a:xfrm>
+            <a:off x="3675888" y="2395728"/>
+            <a:ext cx="2103120" cy="621792"/>
+          </a:xfrm>
+          <a:prstGeom prst="rect">
+            <a:avLst/>
+          </a:prstGeom>
+          <a:noFill/>
+          <a:ln/>
+        </p:spPr>
+        <p:txBody>
+          <a:bodyPr wrap="square" lIns="0" tIns="0" rIns="0" bIns="0" rtlCol="0" anchor="ctr"/>
+          <a:lstStyle/>
+          <a:p>
+            <a:pPr algn="ctr" indent="0" marL="0">
+              <a:buNone/>
+            </a:pPr>
+            <a:r>
+              <a:rPr lang="en-US" sz="3400" dirty="0">
+                <a:solidFill>
+                  <a:srgbClr val="1D1E24"/>
+                </a:solidFill>
+                <a:latin typeface="Georgia" pitchFamily="34" charset="0"/>
+                <a:ea typeface="Georgia" pitchFamily="34" charset="-122"/>
+                <a:cs typeface="Georgia" pitchFamily="34" charset="-120"/>
+              </a:rPr>
+              <a:t>2,400</a:t>
+            </a:r>
+            <a:endParaRPr lang="en-US" sz="3400" dirty="0"/>
+          </a:p>
+        </p:txBody>
+      </p:sp>
+      <p:sp>
+        <p:nvSpPr>
+          <p:cNvPr id="13" name="Text 11"/>
+          <p:cNvSpPr/>
+          <p:nvPr/>
+        </p:nvSpPr>
+        <p:spPr>
+          <a:xfrm>
+            <a:off x="3657600" y="3200400"/>
+            <a:ext cx="2148840" cy="256032"/>
+          </a:xfrm>
+          <a:prstGeom prst="rect">
+            <a:avLst/>
+          </a:prstGeom>
+          <a:noFill/>
+          <a:ln/>
+        </p:spPr>
+        <p:txBody>
+          <a:bodyPr wrap="square" lIns="0" tIns="0" rIns="0" bIns="0" rtlCol="0" anchor="ctr"/>
+          <a:lstStyle/>
+          <a:p>
+            <a:pPr algn="ctr" indent="0" marL="0">
+              <a:buNone/>
+            </a:pPr>
+            <a:r>
+              <a:rPr lang="en-US" sz="1000" b="1" spc="130" kern="0" dirty="0">
+                <a:solidFill>
+                  <a:srgbClr val="77737B"/>
+                </a:solidFill>
+              </a:rPr>
+              <a:t>VALID ACTIONS</a:t>
+            </a:r>
+            <a:endParaRPr lang="en-US" sz="1000" dirty="0"/>
+          </a:p>
+        </p:txBody>
+      </p:sp>
+      <p:sp>
+        <p:nvSpPr>
+          <p:cNvPr id="14" name="Shape 12"/>
+          <p:cNvSpPr/>
+          <p:nvPr/>
+        </p:nvSpPr>
+        <p:spPr>
+          <a:xfrm>
+            <a:off x="6355080" y="1920240"/>
+            <a:ext cx="2514600" cy="1965960"/>
+          </a:xfrm>
+          <a:prstGeom prst="rect">
+            <a:avLst/>
+          </a:prstGeom>
+          <a:solidFill>
+            <a:srgbClr val="FFFFFF"/>
+          </a:solidFill>
+          <a:ln w="12700">
+            <a:solidFill>
+              <a:srgbClr val="D6D1C5"/>
+            </a:solidFill>
+            <a:prstDash val="solid"/>
+          </a:ln>
+        </p:spPr>
+      </p:sp>
+      <p:sp>
+        <p:nvSpPr>
+          <p:cNvPr id="15" name="Shape 13"/>
+          <p:cNvSpPr/>
+          <p:nvPr/>
+        </p:nvSpPr>
+        <p:spPr>
+          <a:xfrm>
+            <a:off x="6355080" y="1920240"/>
+            <a:ext cx="2514600" cy="82296"/>
+          </a:xfrm>
+          <a:prstGeom prst="rect">
+            <a:avLst/>
+          </a:prstGeom>
+          <a:solidFill>
+            <a:srgbClr val="C084FC"/>
+          </a:solidFill>
+          <a:ln w="12700">
+            <a:solidFill>
+              <a:srgbClr val="C084FC"/>
+            </a:solidFill>
+            <a:prstDash val="solid"/>
+          </a:ln>
+        </p:spPr>
+      </p:sp>
+      <p:sp>
+        <p:nvSpPr>
+          <p:cNvPr id="16" name="Text 14"/>
+          <p:cNvSpPr/>
+          <p:nvPr/>
+        </p:nvSpPr>
+        <p:spPr>
+          <a:xfrm>
+            <a:off x="6556248" y="2395728"/>
+            <a:ext cx="2103120" cy="621792"/>
+          </a:xfrm>
+          <a:prstGeom prst="rect">
+            <a:avLst/>
+          </a:prstGeom>
+          <a:noFill/>
+          <a:ln/>
+        </p:spPr>
+        <p:txBody>
+          <a:bodyPr wrap="square" lIns="0" tIns="0" rIns="0" bIns="0" rtlCol="0" anchor="ctr"/>
+          <a:lstStyle/>
+          <a:p>
+            <a:pPr algn="ctr" indent="0" marL="0">
+              <a:buNone/>
+            </a:pPr>
+            <a:r>
+              <a:rPr lang="en-US" sz="3400" dirty="0">
+                <a:solidFill>
+                  <a:srgbClr val="1D1E24"/>
+                </a:solidFill>
+                <a:latin typeface="Georgia" pitchFamily="34" charset="0"/>
+                <a:ea typeface="Georgia" pitchFamily="34" charset="-122"/>
+                <a:cs typeface="Georgia" pitchFamily="34" charset="-120"/>
+              </a:rPr>
+              <a:t>26 → 21</a:t>
+            </a:r>
+            <a:endParaRPr lang="en-US" sz="3400" dirty="0"/>
+          </a:p>
+        </p:txBody>
+      </p:sp>
+      <p:sp>
+        <p:nvSpPr>
+          <p:cNvPr id="17" name="Text 15"/>
+          <p:cNvSpPr/>
+          <p:nvPr/>
+        </p:nvSpPr>
+        <p:spPr>
+          <a:xfrm>
+            <a:off x="6537960" y="3200400"/>
+            <a:ext cx="2148840" cy="256032"/>
+          </a:xfrm>
+          <a:prstGeom prst="rect">
+            <a:avLst/>
+          </a:prstGeom>
+          <a:noFill/>
+          <a:ln/>
+        </p:spPr>
+        <p:txBody>
+          <a:bodyPr wrap="square" lIns="0" tIns="0" rIns="0" bIns="0" rtlCol="0" anchor="ctr"/>
+          <a:lstStyle/>
+          <a:p>
+            <a:pPr algn="ctr" indent="0" marL="0">
+              <a:buNone/>
+            </a:pPr>
+            <a:r>
+              <a:rPr lang="en-US" sz="1000" b="1" spc="130" kern="0" dirty="0">
+                <a:solidFill>
+                  <a:srgbClr val="77737B"/>
+                </a:solidFill>
+              </a:rPr>
+              <a:t>PROPOSED → ACCEPTED</a:t>
+            </a:r>
+            <a:endParaRPr lang="en-US" sz="1000" dirty="0"/>
+          </a:p>
+        </p:txBody>
+      </p:sp>
+      <p:sp>
+        <p:nvSpPr>
+          <p:cNvPr id="18" name="Shape 16"/>
+          <p:cNvSpPr/>
+          <p:nvPr/>
+        </p:nvSpPr>
+        <p:spPr>
+          <a:xfrm>
+            <a:off x="9235440" y="1920240"/>
+            <a:ext cx="2514600" cy="1965960"/>
+          </a:xfrm>
+          <a:prstGeom prst="rect">
+            <a:avLst/>
+          </a:prstGeom>
+          <a:solidFill>
+            <a:srgbClr val="FFFFFF"/>
+          </a:solidFill>
+          <a:ln w="12700">
+            <a:solidFill>
+              <a:srgbClr val="D6D1C5"/>
+            </a:solidFill>
+            <a:prstDash val="solid"/>
+          </a:ln>
+        </p:spPr>
+      </p:sp>
+      <p:sp>
+        <p:nvSpPr>
+          <p:cNvPr id="19" name="Shape 17"/>
+          <p:cNvSpPr/>
+          <p:nvPr/>
+        </p:nvSpPr>
+        <p:spPr>
+          <a:xfrm>
+            <a:off x="9235440" y="1920240"/>
+            <a:ext cx="2514600" cy="82296"/>
+          </a:xfrm>
+          <a:prstGeom prst="rect">
+            <a:avLst/>
+          </a:prstGeom>
+          <a:solidFill>
+            <a:srgbClr val="EF8354"/>
+          </a:solidFill>
+          <a:ln w="12700">
+            <a:solidFill>
+              <a:srgbClr val="EF8354"/>
+            </a:solidFill>
+            <a:prstDash val="solid"/>
+          </a:ln>
+        </p:spPr>
+      </p:sp>
+      <p:sp>
+        <p:nvSpPr>
+          <p:cNvPr id="20" name="Text 18"/>
+          <p:cNvSpPr/>
+          <p:nvPr/>
+        </p:nvSpPr>
+        <p:spPr>
+          <a:xfrm>
+            <a:off x="9436608" y="2395728"/>
+            <a:ext cx="2103120" cy="621792"/>
+          </a:xfrm>
+          <a:prstGeom prst="rect">
+            <a:avLst/>
+          </a:prstGeom>
+          <a:noFill/>
+          <a:ln/>
+        </p:spPr>
+        <p:txBody>
+          <a:bodyPr wrap="square" lIns="0" tIns="0" rIns="0" bIns="0" rtlCol="0" anchor="ctr"/>
+          <a:lstStyle/>
+          <a:p>
+            <a:pPr algn="ctr" indent="0" marL="0">
+              <a:buNone/>
+            </a:pPr>
+            <a:r>
+              <a:rPr lang="en-US" sz="3400" dirty="0">
+                <a:solidFill>
+                  <a:srgbClr val="1D1E24"/>
+                </a:solidFill>
+                <a:latin typeface="Georgia" pitchFamily="34" charset="0"/>
+                <a:ea typeface="Georgia" pitchFamily="34" charset="-122"/>
+                <a:cs typeface="Georgia" pitchFamily="34" charset="-120"/>
+              </a:rPr>
+              <a:t>$7.34</a:t>
+            </a:r>
+            <a:endParaRPr lang="en-US" sz="3400" dirty="0"/>
+          </a:p>
+        </p:txBody>
+      </p:sp>
+      <p:sp>
+        <p:nvSpPr>
+          <p:cNvPr id="21" name="Text 19"/>
+          <p:cNvSpPr/>
+          <p:nvPr/>
+        </p:nvSpPr>
+        <p:spPr>
+          <a:xfrm>
+            <a:off x="9418320" y="3200400"/>
+            <a:ext cx="2148840" cy="256032"/>
+          </a:xfrm>
+          <a:prstGeom prst="rect">
+            <a:avLst/>
+          </a:prstGeom>
+          <a:noFill/>
+          <a:ln/>
+        </p:spPr>
+        <p:txBody>
+          <a:bodyPr wrap="square" lIns="0" tIns="0" rIns="0" bIns="0" rtlCol="0" anchor="ctr"/>
+          <a:lstStyle/>
+          <a:p>
+            <a:pPr algn="ctr" indent="0" marL="0">
+              <a:buNone/>
+            </a:pPr>
+            <a:r>
+              <a:rPr lang="en-US" sz="1000" b="1" spc="130" kern="0" dirty="0">
+                <a:solidFill>
+                  <a:srgbClr val="77737B"/>
+                </a:solidFill>
+              </a:rPr>
+              <a:t>TOTAL MODEL COST</a:t>
+            </a:r>
+            <a:endParaRPr lang="en-US" sz="1000" dirty="0"/>
+          </a:p>
+        </p:txBody>
+      </p:sp>
+      <p:sp>
+        <p:nvSpPr>
+          <p:cNvPr id="22" name="Text 20"/>
+          <p:cNvSpPr/>
+          <p:nvPr/>
+        </p:nvSpPr>
+        <p:spPr>
+          <a:xfrm>
+            <a:off x="914400" y="4709160"/>
+            <a:ext cx="2194560" cy="438912"/>
+          </a:xfrm>
+          <a:prstGeom prst="rect">
+            <a:avLst/>
+          </a:prstGeom>
+          <a:noFill/>
+          <a:ln/>
+        </p:spPr>
+        <p:txBody>
+          <a:bodyPr wrap="square" lIns="0" tIns="0" rIns="0" bIns="0" rtlCol="0" anchor="ctr"/>
+          <a:lstStyle/>
+          <a:p>
+            <a:pPr indent="0" marL="0">
+              <a:buNone/>
+            </a:pPr>
+            <a:r>
+              <a:rPr lang="en-US" sz="2700" dirty="0">
+                <a:solidFill>
+                  <a:srgbClr val="1D1E24"/>
+                </a:solidFill>
+                <a:latin typeface="Georgia" pitchFamily="34" charset="0"/>
+                <a:ea typeface="Georgia" pitchFamily="34" charset="-122"/>
+                <a:cs typeface="Georgia" pitchFamily="34" charset="-120"/>
+              </a:rPr>
+              <a:t>Brine</a:t>
+            </a:r>
+            <a:endParaRPr lang="en-US" sz="2700" dirty="0"/>
+          </a:p>
+        </p:txBody>
+      </p:sp>
+      <p:sp>
+        <p:nvSpPr>
+          <p:cNvPr id="23" name="Text 21"/>
+          <p:cNvSpPr/>
+          <p:nvPr/>
+        </p:nvSpPr>
+        <p:spPr>
+          <a:xfrm>
+            <a:off x="914400" y="5230368"/>
+            <a:ext cx="2560320" cy="274320"/>
+          </a:xfrm>
+          <a:prstGeom prst="rect">
+            <a:avLst/>
+          </a:prstGeom>
+          <a:noFill/>
+          <a:ln/>
+        </p:spPr>
+        <p:txBody>
+          <a:bodyPr wrap="square" lIns="0" tIns="0" rIns="0" bIns="0" rtlCol="0" anchor="ctr"/>
+          <a:lstStyle/>
+          <a:p>
+            <a:pPr indent="0" marL="0">
+              <a:buNone/>
+            </a:pPr>
+            <a:r>
+              <a:rPr lang="en-US" sz="1300" dirty="0">
+                <a:solidFill>
+                  <a:srgbClr val="65626A"/>
+                </a:solidFill>
+              </a:rPr>
+              <a:t>318 influence · final leader</a:t>
+            </a:r>
+            <a:endParaRPr lang="en-US" sz="1300" dirty="0"/>
+          </a:p>
+        </p:txBody>
+      </p:sp>
+      <p:sp>
+        <p:nvSpPr>
+          <p:cNvPr id="24" name="Shape 22"/>
+          <p:cNvSpPr/>
+          <p:nvPr/>
+        </p:nvSpPr>
+        <p:spPr>
+          <a:xfrm>
+            <a:off x="3749040" y="5120640"/>
+            <a:ext cx="914400" cy="0"/>
+          </a:xfrm>
+          <a:prstGeom prst="line">
+            <a:avLst/>
+          </a:prstGeom>
+          <a:noFill/>
+          <a:ln w="38100">
+            <a:solidFill>
+              <a:srgbClr val="D5BF55"/>
+            </a:solidFill>
+            <a:prstDash val="solid"/>
+          </a:ln>
+        </p:spPr>
+      </p:sp>
+      <p:sp>
+        <p:nvSpPr>
+          <p:cNvPr id="25" name="Text 23"/>
+          <p:cNvSpPr/>
+          <p:nvPr/>
+        </p:nvSpPr>
+        <p:spPr>
+          <a:xfrm>
+            <a:off x="4937760" y="4681728"/>
+            <a:ext cx="6035040" cy="960120"/>
+          </a:xfrm>
+          <a:prstGeom prst="rect">
+            <a:avLst/>
+          </a:prstGeom>
+          <a:noFill/>
+          <a:ln/>
+        </p:spPr>
+        <p:txBody>
+          <a:bodyPr wrap="square" lIns="0" tIns="0" rIns="0" bIns="0" rtlCol="0" anchor="ctr"/>
+          <a:lstStyle/>
+          <a:p>
+            <a:pPr indent="0" marL="0">
+              <a:buNone/>
+            </a:pPr>
+            <a:r>
+              <a:rPr lang="en-US" sz="2100" dirty="0">
+                <a:solidFill>
+                  <a:srgbClr val="292A31"/>
+                </a:solidFill>
+                <a:latin typeface="Georgia" pitchFamily="34" charset="0"/>
+                <a:ea typeface="Georgia" pitchFamily="34" charset="-122"/>
+                <a:cs typeface="Georgia" pitchFamily="34" charset="-120"/>
+              </a:rPr>
+              <a:t>Making was rare, costly, and consequential: accepted authors accumulated hundreds of later choices.</a:t>
+            </a:r>
+            <a:endParaRPr lang="en-US" sz="2100" dirty="0"/>
           </a:p>
         </p:txBody>
       </p:sp>

</xml_diff>